<commit_message>
docs: reincorporar a Francisco Reyes Santiago en portadas, tablas y diapositiva inicial con division equilibrada de carga tecnica
</commit_message>
<xml_diff>
--- a/01_DOCUMENTOS_ACADEMICOS_FIME/Presentacion_ExpendeX_Canva_Design_Animada.pptx
+++ b/01_DOCUMENTOS_ACADEMICOS_FIME/Presentacion_ExpendeX_Canva_Design_Animada.pptx
@@ -316,7 +316,7 @@
           <a:p>
             <a:fld id="{5BCAD085-E8A6-8845-BD4E-CB4CCA059FC4}" type="datetimeFigureOut">
               <a:rPr lang="en-US" smtClean="0"/>
-              <a:t>10/24/2026</a:t>
+              <a:t>10/26/2026</a:t>
             </a:fld>
             <a:endParaRPr lang="en-US"/>
           </a:p>
@@ -484,7 +484,7 @@
           <a:p>
             <a:fld id="{5BCAD085-E8A6-8845-BD4E-CB4CCA059FC4}" type="datetimeFigureOut">
               <a:rPr lang="en-US" smtClean="0"/>
-              <a:t>10/24/2026</a:t>
+              <a:t>10/26/2026</a:t>
             </a:fld>
             <a:endParaRPr lang="en-US"/>
           </a:p>
@@ -662,7 +662,7 @@
           <a:p>
             <a:fld id="{5BCAD085-E8A6-8845-BD4E-CB4CCA059FC4}" type="datetimeFigureOut">
               <a:rPr lang="en-US" smtClean="0"/>
-              <a:t>10/24/2026</a:t>
+              <a:t>10/26/2026</a:t>
             </a:fld>
             <a:endParaRPr lang="en-US"/>
           </a:p>
@@ -830,7 +830,7 @@
           <a:p>
             <a:fld id="{5BCAD085-E8A6-8845-BD4E-CB4CCA059FC4}" type="datetimeFigureOut">
               <a:rPr lang="en-US" smtClean="0"/>
-              <a:t>10/24/2026</a:t>
+              <a:t>10/26/2026</a:t>
             </a:fld>
             <a:endParaRPr lang="en-US"/>
           </a:p>
@@ -1075,7 +1075,7 @@
           <a:p>
             <a:fld id="{5BCAD085-E8A6-8845-BD4E-CB4CCA059FC4}" type="datetimeFigureOut">
               <a:rPr lang="en-US" smtClean="0"/>
-              <a:t>10/24/2026</a:t>
+              <a:t>10/26/2026</a:t>
             </a:fld>
             <a:endParaRPr lang="en-US"/>
           </a:p>
@@ -1360,7 +1360,7 @@
           <a:p>
             <a:fld id="{5BCAD085-E8A6-8845-BD4E-CB4CCA059FC4}" type="datetimeFigureOut">
               <a:rPr lang="en-US" smtClean="0"/>
-              <a:t>10/24/2026</a:t>
+              <a:t>10/26/2026</a:t>
             </a:fld>
             <a:endParaRPr lang="en-US"/>
           </a:p>
@@ -1779,7 +1779,7 @@
           <a:p>
             <a:fld id="{5BCAD085-E8A6-8845-BD4E-CB4CCA059FC4}" type="datetimeFigureOut">
               <a:rPr lang="en-US" smtClean="0"/>
-              <a:t>10/24/2026</a:t>
+              <a:t>10/26/2026</a:t>
             </a:fld>
             <a:endParaRPr lang="en-US"/>
           </a:p>
@@ -1896,7 +1896,7 @@
           <a:p>
             <a:fld id="{5BCAD085-E8A6-8845-BD4E-CB4CCA059FC4}" type="datetimeFigureOut">
               <a:rPr lang="en-US" smtClean="0"/>
-              <a:t>10/24/2026</a:t>
+              <a:t>10/26/2026</a:t>
             </a:fld>
             <a:endParaRPr lang="en-US"/>
           </a:p>
@@ -1991,7 +1991,7 @@
           <a:p>
             <a:fld id="{5BCAD085-E8A6-8845-BD4E-CB4CCA059FC4}" type="datetimeFigureOut">
               <a:rPr lang="en-US" smtClean="0"/>
-              <a:t>10/24/2026</a:t>
+              <a:t>10/26/2026</a:t>
             </a:fld>
             <a:endParaRPr lang="en-US"/>
           </a:p>
@@ -2266,7 +2266,7 @@
           <a:p>
             <a:fld id="{5BCAD085-E8A6-8845-BD4E-CB4CCA059FC4}" type="datetimeFigureOut">
               <a:rPr lang="en-US" smtClean="0"/>
-              <a:t>10/24/2026</a:t>
+              <a:t>10/26/2026</a:t>
             </a:fld>
             <a:endParaRPr lang="en-US"/>
           </a:p>
@@ -2518,7 +2518,7 @@
           <a:p>
             <a:fld id="{5BCAD085-E8A6-8845-BD4E-CB4CCA059FC4}" type="datetimeFigureOut">
               <a:rPr lang="en-US" smtClean="0"/>
-              <a:t>10/24/2026</a:t>
+              <a:t>10/26/2026</a:t>
             </a:fld>
             <a:endParaRPr lang="en-US"/>
           </a:p>
@@ -2729,7 +2729,7 @@
           <a:p>
             <a:fld id="{5BCAD085-E8A6-8845-BD4E-CB4CCA059FC4}" type="datetimeFigureOut">
               <a:rPr lang="en-US" smtClean="0"/>
-              <a:t>10/24/2026</a:t>
+              <a:t>10/26/2026</a:t>
             </a:fld>
             <a:endParaRPr lang="en-US"/>
           </a:p>
@@ -3440,8 +3440,8 @@
         </p:nvSpPr>
         <p:spPr>
           <a:xfrm>
-            <a:off x="822960" y="4160520"/>
-            <a:ext cx="6126480" cy="1920240"/>
+            <a:off x="822960" y="3977639"/>
+            <a:ext cx="6126480" cy="2148840"/>
           </a:xfrm>
           <a:prstGeom prst="rect">
             <a:avLst/>
@@ -3493,7 +3493,7 @@
                 </a:solidFill>
                 <a:latin typeface="Calibri"/>
               </a:rPr>
-              <a:t>• Compañero de Equipo: </a:t>
+              <a:t>• Emiliano Sánchez Martínez (Mat. 2012856): </a:t>
             </a:r>
             <a:r>
               <a:rPr sz="880">
@@ -3502,7 +3502,27 @@
                 </a:solidFill>
                 <a:latin typeface="Calibri"/>
               </a:rPr>
-              <a:t>Desarrollo de Plataforma Web Dual (Quiosco 10.1" y Panel Admin /admin) y Diseño/Simulación de Electrónica de Potencia en EasyEDA.</a:t>
+              <a:t>Desarrollo de Plataforma Web Dual (Quiosco Táctil 10.1" con QR Mercado Pago y Panel Admin /admin con gestión FIFO).</a:t>
+            </a:r>
+          </a:p>
+          <a:p>
+            <a:r>
+              <a:rPr sz="900" b="1">
+                <a:solidFill>
+                  <a:srgbClr val="06B6D4"/>
+                </a:solidFill>
+                <a:latin typeface="Calibri"/>
+              </a:rPr>
+              <a:t>• Francisco Reyes Santiago (Mat. 1768161): </a:t>
+            </a:r>
+            <a:r>
+              <a:rPr sz="880">
+                <a:solidFill>
+                  <a:srgbClr val="F1F5F9"/>
+                </a:solidFill>
+                <a:latin typeface="Calibri"/>
+              </a:rPr>
+              <a:t>Diseño y Simulación de Electrónica de Potencia en EasyEDA (Matriz MOSFET 6x6, optoacopladores PC817C, IPC-2221B) y Simulación Digital.</a:t>
             </a:r>
           </a:p>
         </p:txBody>

</xml_diff>

<commit_message>
fix(portadas): eliminar coordinacion y diseno tecnico, anadir repositorio en portada, remover llamadas internas y actualizar presentacion
</commit_message>
<xml_diff>
--- a/01_DOCUMENTOS_ACADEMICOS_FIME/Presentacion_ExpendeX_Canva_Design_Animada.pptx
+++ b/01_DOCUMENTOS_ACADEMICOS_FIME/Presentacion_ExpendeX_Canva_Design_Animada.pptx
@@ -5033,8 +5033,8 @@
         </p:nvSpPr>
         <p:spPr>
           <a:xfrm>
-            <a:off x="822960" y="2880360"/>
-            <a:ext cx="6126480" cy="868680"/>
+            <a:off x="822960" y="2788920"/>
+            <a:ext cx="6126480" cy="594360"/>
           </a:xfrm>
           <a:prstGeom prst="rect">
             <a:avLst/>
@@ -5048,7 +5048,7 @@
           <a:lstStyle/>
           <a:p>
             <a:r>
-              <a:rPr sz="1300" b="1">
+              <a:rPr sz="1200" b="1">
                 <a:solidFill>
                   <a:srgbClr val="06B6D4"/>
                 </a:solidFill>
@@ -5067,8 +5067,51 @@
         </p:nvSpPr>
         <p:spPr>
           <a:xfrm>
-            <a:off x="822960" y="3886200"/>
-            <a:ext cx="6126480" cy="2240280"/>
+            <a:off x="822960" y="3401568"/>
+            <a:ext cx="6126480" cy="347472"/>
+          </a:xfrm>
+          <a:prstGeom prst="rect">
+            <a:avLst/>
+          </a:prstGeom>
+          <a:noFill/>
+        </p:spPr>
+        <p:txBody>
+          <a:bodyPr wrap="none">
+            <a:spAutoFit/>
+          </a:bodyPr>
+          <a:lstStyle/>
+          <a:p>
+            <a:r>
+              <a:rPr sz="950" b="1">
+                <a:solidFill>
+                  <a:srgbClr val="10B981"/>
+                </a:solidFill>
+                <a:latin typeface="Segoe UI"/>
+              </a:rPr>
+              <a:t>Repositorio Oficial GitHub (Acceso Abierto): </a:t>
+            </a:r>
+            <a:r>
+              <a:rPr sz="950" b="1">
+                <a:solidFill>
+                  <a:srgbClr val="06B6D4"/>
+                </a:solidFill>
+                <a:latin typeface="Segoe UI"/>
+              </a:rPr>
+              <a:t>https://github.com/Anubys6/ExpendeX-Smart-Vending-FIME</a:t>
+            </a:r>
+          </a:p>
+        </p:txBody>
+      </p:sp>
+      <p:sp>
+        <p:nvSpPr>
+          <p:cNvPr id="11" name="TextBox 10"/>
+          <p:cNvSpPr txBox="1"/>
+          <p:nvPr/>
+        </p:nvSpPr>
+        <p:spPr>
+          <a:xfrm>
+            <a:off x="822960" y="3822191"/>
+            <a:ext cx="6126480" cy="2331720"/>
           </a:xfrm>
           <a:prstGeom prst="rect">
             <a:avLst/>
@@ -5170,7 +5213,7 @@
       </p:sp>
       <p:sp>
         <p:nvSpPr>
-          <p:cNvPr id="11" name="Rounded Rectangle 10"/>
+          <p:cNvPr id="12" name="Rounded Rectangle 11"/>
           <p:cNvSpPr/>
           <p:nvPr/>
         </p:nvSpPr>
@@ -5217,7 +5260,7 @@
       </p:sp>
       <p:pic>
         <p:nvPicPr>
-          <p:cNvPr id="12" name="Picture 11" descr="02_Vista_Isometrica_Frontal_Derecha_CAD_Final.png"/>
+          <p:cNvPr id="13" name="Picture 12" descr="02_Vista_Isometrica_Frontal_Derecha_CAD_Final.png"/>
           <p:cNvPicPr>
             <a:picLocks noChangeAspect="1"/>
           </p:cNvPicPr>
@@ -5241,7 +5284,7 @@
       </p:pic>
       <p:sp>
         <p:nvSpPr>
-          <p:cNvPr id="13" name="TextBox 12"/>
+          <p:cNvPr id="14" name="TextBox 13"/>
           <p:cNvSpPr txBox="1"/>
           <p:nvPr/>
         </p:nvSpPr>
@@ -5276,7 +5319,7 @@
       </p:sp>
       <p:sp>
         <p:nvSpPr>
-          <p:cNvPr id="14" name="Rectangle 13"/>
+          <p:cNvPr id="15" name="Rectangle 14"/>
           <p:cNvSpPr/>
           <p:nvPr/>
         </p:nvSpPr>
@@ -5321,7 +5364,7 @@
       </p:sp>
       <p:sp>
         <p:nvSpPr>
-          <p:cNvPr id="15" name="TextBox 14"/>
+          <p:cNvPr id="16" name="TextBox 15"/>
           <p:cNvSpPr txBox="1"/>
           <p:nvPr/>
         </p:nvSpPr>
@@ -5355,7 +5398,7 @@
       </p:sp>
       <p:sp>
         <p:nvSpPr>
-          <p:cNvPr id="16" name="TextBox 15"/>
+          <p:cNvPr id="17" name="TextBox 16"/>
           <p:cNvSpPr txBox="1"/>
           <p:nvPr/>
         </p:nvSpPr>

</xml_diff>